<commit_message>
docs: rewrite slide deck in the presenter's voice, add speaker notes and real screenshots
Co-Authored-By: Claude Sonnet 5 <noreply@anthropic.com>
</commit_message>
<xml_diff>
--- a/docs/webplat-kubernetes-showcase.pptx
+++ b/docs/webplat-kubernetes-showcase.pptx
@@ -512,7 +512,7 @@
           <a:p>
             <a:r>
               <a:rPr lang="en-US" dirty="0"/>
-              <a:t/>
+              <a:t>Thanks for having me. Over the next few minutes I'll walk you through a platform I designed and built myself: a private Kubernetes cluster on Azure, deployed through a pipeline with no stored passwords. I'll show you the design, and I'll also show you the day it broke, because that is where I learned the most.</a:t>
             </a:r>
             <a:endParaRPr lang="en-US" dirty="0"/>
           </a:p>
@@ -600,7 +600,7 @@
           <a:p>
             <a:r>
               <a:rPr lang="en-US" dirty="0"/>
-              <a:t/>
+              <a:t>I don't want you to take my word for it. On the left is the real output of kubectl get nodes against prod, run the way my pipeline runs it, through Azure and not over a VPN. Below it is the Azure portal showing the dev and prod resource groups. The full set of evidence is in the repository, and everything here has been cropped so no account details are shown.</a:t>
             </a:r>
             <a:endParaRPr lang="en-US" dirty="0"/>
           </a:p>
@@ -688,7 +688,7 @@
           <a:p>
             <a:r>
               <a:rPr lang="en-US" dirty="0"/>
-              <a:t/>
+              <a:t>To sum up: I can design a private, zero-secret Kubernetes platform on Azure, automate its delivery, and when it breaks in production, work through it methodically. The repository has everything, including the incident write-up. I'm happy to take questions, and to go deeper on any slide.</a:t>
             </a:r>
             <a:endParaRPr lang="en-US" dirty="0"/>
           </a:p>
@@ -776,7 +776,7 @@
           <a:p>
             <a:r>
               <a:rPr lang="en-US" dirty="0"/>
-              <a:t/>
+              <a:t>In one sentence: it's a website running on Kubernetes that I locked down properly. Two environments, dev and prod. The API server has no public address, and nothing in the pipeline holds a password or key. I'll show you proof of both environments later, from the live Azure portal and the command line.</a:t>
             </a:r>
             <a:endParaRPr lang="en-US" dirty="0"/>
           </a:p>
@@ -864,7 +864,7 @@
           <a:p>
             <a:r>
               <a:rPr lang="en-US" dirty="0"/>
-              <a:t/>
+              <a:t>Follow a visitor's request from the top. It arrives at the Application Gateway, where the WAF filters it and TLS ends. The Gateway forwards to pods in the AKS cluster. I split the cluster into a system pool that only runs Azure's own add-ons and a user pool for my app, which autoscales. Underneath sit two private services: the container registry that holds my images and Key Vault that holds the TLS certificate. Neither is reachable from the internet.</a:t>
             </a:r>
             <a:endParaRPr lang="en-US" dirty="0"/>
           </a:p>
@@ -952,7 +952,7 @@
           <a:p>
             <a:r>
               <a:rPr lang="en-US" dirty="0"/>
-              <a:t/>
+              <a:t>If you're not a Kubernetes person, read this as a checklist of what I configured. The two I care about most are the default-deny network policy, which means pods can't talk to each other or out unless I say so, and the container settings: non-root, read-only filesystem, all Linux capabilities dropped.</a:t>
             </a:r>
             <a:endParaRPr lang="en-US" dirty="0"/>
           </a:p>
@@ -1040,7 +1040,7 @@
           <a:p>
             <a:r>
               <a:rPr lang="en-US" dirty="0"/>
-              <a:t/>
+              <a:t>Six decisions, all made up front rather than bolted on. The one people ask about most is the second: my pipeline logs into Azure with short-lived federated tokens, so there is no client secret in GitHub to steal or rotate. The same idea applies to the registry, Key Vault and the Gateway: they all use managed identities.</a:t>
             </a:r>
             <a:endParaRPr lang="en-US" dirty="0"/>
           </a:p>
@@ -1128,7 +1128,7 @@
           <a:p>
             <a:r>
               <a:rPr lang="en-US" dirty="0"/>
-              <a:t/>
+              <a:t>This is the path from a code change to a running pod. The design problem I had to solve is that a private cluster can't be reached from a normal build runner. I used command invoke so the pipeline can still deploy without opening any network path. Dev deploys automatically, and prod waits for a human approval.</a:t>
             </a:r>
             <a:endParaRPr lang="en-US" dirty="0"/>
           </a:p>
@@ -1216,7 +1216,7 @@
           <a:p>
             <a:r>
               <a:rPr lang="en-US" dirty="0"/>
-              <a:t/>
+              <a:t>This is the slide I'm most glad to show. After I deployed prod, the pods were stuck and I didn't spot it for a day. Fixing it meant peeling back five separate problems, and each fix exposed the next. The first was a placeholder I forgot to patch in prod's config. The last was a manual step I took mid-recovery that skipped the pipeline's image substitution. What I took from it: put a check on pod readiness in the pipeline, and don't do manual applies during a recovery.</a:t>
             </a:r>
             <a:endParaRPr lang="en-US" dirty="0"/>
           </a:p>
@@ -1304,7 +1304,7 @@
           <a:p>
             <a:r>
               <a:rPr lang="en-US" dirty="0"/>
-              <a:t/>
+              <a:t>A quick glossary so nobody gets lost. If you only remember three: a pod is one running copy of the app, a Deployment keeps N pods alive, and an Ingress is a routing rule that the Application Gateway turns into real configuration.</a:t>
             </a:r>
             <a:endParaRPr lang="en-US" dirty="0"/>
           </a:p>
@@ -1392,7 +1392,7 @@
           <a:p>
             <a:r>
               <a:rPr lang="en-US" dirty="0"/>
-              <a:t/>
+              <a:t>This isn't only a lab. I'd use this same pattern for a company website with an availability target, for internal line-of-business apps that need a public front door, and as a reference for clients whose procurement teams ask hard security questions.</a:t>
             </a:r>
             <a:endParaRPr lang="en-US" dirty="0"/>
           </a:p>
@@ -1884,7 +1884,7 @@
                 <a:ea typeface="Calibri" pitchFamily="34" charset="-122"/>
                 <a:cs typeface="Calibri" pitchFamily="34" charset="-120"/>
               </a:rPr>
-              <a:t>A private AKS platform — designed, deployed, broken, diagnosed,</a:t>
+              <a:t>How I designed, deployed, broke, diagnosed and fixed</a:t>
             </a:r>
             <a:endParaRPr lang="en-US" sz="1700" dirty="0"/>
           </a:p>
@@ -1904,7 +1904,7 @@
                 <a:ea typeface="Calibri" pitchFamily="34" charset="-122"/>
                 <a:cs typeface="Calibri" pitchFamily="34" charset="-120"/>
               </a:rPr>
-              <a:t>and fixed end-to-end on real Azure infrastructure</a:t>
+              <a:t>a private AKS platform on real Azure infrastructure</a:t>
             </a:r>
             <a:endParaRPr lang="en-US" sz="1700" dirty="0"/>
           </a:p>
@@ -2009,7 +2009,7 @@
                 <a:ea typeface="Calibri" pitchFamily="34" charset="-122"/>
                 <a:cs typeface="Calibri" pitchFamily="34" charset="-120"/>
               </a:rPr>
-              <a:t>Sufyan Deen-Gabisi   ·   github.com/sufideen/az-ent-sec-dashboard</a:t>
+              <a:t>Presented by Sufyan Deen-Gabisi   ·   github.com/sufideen/az-ent-sec-dashboard</a:t>
             </a:r>
             <a:endParaRPr lang="en-US" sz="1100" dirty="0"/>
           </a:p>
@@ -2163,7 +2163,7 @@
                 <a:ea typeface="Calibri" pitchFamily="34" charset="-122"/>
                 <a:cs typeface="Calibri" pitchFamily="34" charset="-120"/>
               </a:rPr>
-              <a:t>Real command output, captured live from both environments</a:t>
+              <a:t>Everything below was captured from my own Azure tenant, not mocked up</a:t>
             </a:r>
             <a:endParaRPr lang="en-US" sz="1300" dirty="0"/>
           </a:p>
@@ -2177,12 +2177,12 @@
         </p:nvSpPr>
         <p:spPr>
           <a:xfrm>
-            <a:off x="548640" y="1508760"/>
-            <a:ext cx="3566160" cy="1920240"/>
+            <a:off x="548640" y="1463040"/>
+            <a:ext cx="3566160" cy="1783080"/>
           </a:xfrm>
           <a:prstGeom prst="roundRect">
             <a:avLst>
-              <a:gd name="adj" fmla="val 3810"/>
+              <a:gd name="adj" fmla="val 4103"/>
             </a:avLst>
           </a:prstGeom>
           <a:solidFill>
@@ -2204,7 +2204,7 @@
         </p:nvSpPr>
         <p:spPr>
           <a:xfrm>
-            <a:off x="713232" y="1655064"/>
+            <a:off x="713232" y="1609344"/>
             <a:ext cx="109728" cy="109728"/>
           </a:xfrm>
           <a:prstGeom prst="ellipse">
@@ -2224,7 +2224,7 @@
         </p:nvSpPr>
         <p:spPr>
           <a:xfrm>
-            <a:off x="896112" y="1655064"/>
+            <a:off x="896112" y="1609344"/>
             <a:ext cx="109728" cy="109728"/>
           </a:xfrm>
           <a:prstGeom prst="ellipse">
@@ -2244,7 +2244,7 @@
         </p:nvSpPr>
         <p:spPr>
           <a:xfrm>
-            <a:off x="1078992" y="1655064"/>
+            <a:off x="1078992" y="1609344"/>
             <a:ext cx="109728" cy="109728"/>
           </a:xfrm>
           <a:prstGeom prst="ellipse">
@@ -2264,7 +2264,7 @@
         </p:nvSpPr>
         <p:spPr>
           <a:xfrm>
-            <a:off x="1280160" y="1572768"/>
+            <a:off x="1280160" y="1527048"/>
             <a:ext cx="2651760" cy="274320"/>
           </a:xfrm>
           <a:prstGeom prst="rect">
@@ -2303,8 +2303,8 @@
         </p:nvSpPr>
         <p:spPr>
           <a:xfrm>
-            <a:off x="777240" y="1920240"/>
-            <a:ext cx="3108960" cy="1371600"/>
+            <a:off x="777240" y="1874520"/>
+            <a:ext cx="3108960" cy="1234440"/>
           </a:xfrm>
           <a:prstGeom prst="rect">
             <a:avLst/>
@@ -2414,12 +2414,12 @@
         </p:nvSpPr>
         <p:spPr>
           <a:xfrm>
-            <a:off x="4343400" y="1508760"/>
-            <a:ext cx="3566160" cy="1920240"/>
+            <a:off x="4343400" y="1463040"/>
+            <a:ext cx="3566160" cy="1783080"/>
           </a:xfrm>
           <a:prstGeom prst="roundRect">
             <a:avLst>
-              <a:gd name="adj" fmla="val 3810"/>
+              <a:gd name="adj" fmla="val 4103"/>
             </a:avLst>
           </a:prstGeom>
           <a:solidFill>
@@ -2441,7 +2441,7 @@
         </p:nvSpPr>
         <p:spPr>
           <a:xfrm>
-            <a:off x="4507992" y="1655064"/>
+            <a:off x="4507992" y="1609344"/>
             <a:ext cx="109728" cy="109728"/>
           </a:xfrm>
           <a:prstGeom prst="ellipse">
@@ -2461,7 +2461,7 @@
         </p:nvSpPr>
         <p:spPr>
           <a:xfrm>
-            <a:off x="4690872" y="1655064"/>
+            <a:off x="4690872" y="1609344"/>
             <a:ext cx="109728" cy="109728"/>
           </a:xfrm>
           <a:prstGeom prst="ellipse">
@@ -2481,7 +2481,7 @@
         </p:nvSpPr>
         <p:spPr>
           <a:xfrm>
-            <a:off x="4873752" y="1655064"/>
+            <a:off x="4873752" y="1609344"/>
             <a:ext cx="109728" cy="109728"/>
           </a:xfrm>
           <a:prstGeom prst="ellipse">
@@ -2501,7 +2501,7 @@
         </p:nvSpPr>
         <p:spPr>
           <a:xfrm>
-            <a:off x="5074920" y="1572768"/>
+            <a:off x="5074920" y="1527048"/>
             <a:ext cx="2651760" cy="274320"/>
           </a:xfrm>
           <a:prstGeom prst="rect">
@@ -2540,8 +2540,8 @@
         </p:nvSpPr>
         <p:spPr>
           <a:xfrm>
-            <a:off x="4572000" y="1920240"/>
-            <a:ext cx="3108960" cy="1371600"/>
+            <a:off x="4572000" y="1874520"/>
+            <a:ext cx="3108960" cy="1234440"/>
           </a:xfrm>
           <a:prstGeom prst="rect">
             <a:avLst/>
@@ -2642,12 +2642,12 @@
         </p:nvSpPr>
         <p:spPr>
           <a:xfrm>
-            <a:off x="8138160" y="1508760"/>
-            <a:ext cx="3502152" cy="1920240"/>
+            <a:off x="8138160" y="1463040"/>
+            <a:ext cx="3502152" cy="1783080"/>
           </a:xfrm>
           <a:prstGeom prst="roundRect">
             <a:avLst>
-              <a:gd name="adj" fmla="val 3810"/>
+              <a:gd name="adj" fmla="val 4103"/>
             </a:avLst>
           </a:prstGeom>
           <a:solidFill>
@@ -2669,7 +2669,7 @@
         </p:nvSpPr>
         <p:spPr>
           <a:xfrm>
-            <a:off x="8302752" y="1655064"/>
+            <a:off x="8302752" y="1609344"/>
             <a:ext cx="109728" cy="109728"/>
           </a:xfrm>
           <a:prstGeom prst="ellipse">
@@ -2689,7 +2689,7 @@
         </p:nvSpPr>
         <p:spPr>
           <a:xfrm>
-            <a:off x="8485632" y="1655064"/>
+            <a:off x="8485632" y="1609344"/>
             <a:ext cx="109728" cy="109728"/>
           </a:xfrm>
           <a:prstGeom prst="ellipse">
@@ -2709,7 +2709,7 @@
         </p:nvSpPr>
         <p:spPr>
           <a:xfrm>
-            <a:off x="8668512" y="1655064"/>
+            <a:off x="8668512" y="1609344"/>
             <a:ext cx="109728" cy="109728"/>
           </a:xfrm>
           <a:prstGeom prst="ellipse">
@@ -2729,7 +2729,7 @@
         </p:nvSpPr>
         <p:spPr>
           <a:xfrm>
-            <a:off x="8869680" y="1572768"/>
+            <a:off x="8869680" y="1527048"/>
             <a:ext cx="2587752" cy="274320"/>
           </a:xfrm>
           <a:prstGeom prst="rect">
@@ -2768,8 +2768,8 @@
         </p:nvSpPr>
         <p:spPr>
           <a:xfrm>
-            <a:off x="8366760" y="1920240"/>
-            <a:ext cx="3044952" cy="1371600"/>
+            <a:off x="8366760" y="1874520"/>
+            <a:ext cx="3044952" cy="1234440"/>
           </a:xfrm>
           <a:prstGeom prst="rect">
             <a:avLst/>
@@ -2851,20 +2851,146 @@
           </a:p>
         </p:txBody>
       </p:sp>
-      <p:sp>
-        <p:nvSpPr>
-          <p:cNvPr id="24" name="Shape 21"/>
+      <p:pic>
+        <p:nvPicPr>
+          <p:cNvPr id="24" name="Image 1" descr="/tmp/claude-1000/-home-sufideen--config-Claude-scratch-workspaces-3637d91f-12c3-4b41-8698-1a9b1c090587-8dbdcacd-85cb-4266-9c51-29022c3bf154-scratch-2026-09-19-0422a7/b88270b6-1dec-4e78-9e04-de6497b56a14/scratchpad/pub/az-ent-sec-dashboard/scripts/slide-deck/assets/prod-nodes-ready.png">    </p:cNvPr>
+          <p:cNvPicPr>
+            <a:picLocks noChangeAspect="1"/>
+          </p:cNvPicPr>
+          <p:nvPr/>
+        </p:nvPicPr>
+        <p:blipFill>
+          <a:blip r:embed="rId2"/>
+          <a:stretch>
+            <a:fillRect/>
+          </a:stretch>
+        </p:blipFill>
+        <p:spPr>
+          <a:xfrm>
+            <a:off x="548640" y="3520440"/>
+            <a:ext cx="7223760" cy="843164"/>
+          </a:xfrm>
+          <a:prstGeom prst="rect">
+            <a:avLst/>
+          </a:prstGeom>
+        </p:spPr>
+      </p:pic>
+      <p:sp>
+        <p:nvSpPr>
+          <p:cNvPr id="25" name="Text 21"/>
+          <p:cNvSpPr txBox="1"/>
+          <p:nvPr/>
+        </p:nvSpPr>
+        <p:spPr>
+          <a:xfrm>
+            <a:off x="548640" y="4409324"/>
+            <a:ext cx="7223760" cy="274320"/>
+          </a:xfrm>
+          <a:prstGeom prst="rect">
+            <a:avLst/>
+          </a:prstGeom>
+          <a:noFill/>
+          <a:ln/>
+        </p:spPr>
+        <p:txBody>
+          <a:bodyPr wrap="square" rtlCol="0" anchor="ctr"/>
+          <a:lstStyle/>
+          <a:p>
+            <a:pPr indent="0" marL="0">
+              <a:buNone/>
+            </a:pPr>
+            <a:r>
+              <a:rPr lang="en-US" sz="950" i="1" dirty="0">
+                <a:solidFill>
+                  <a:srgbClr val="8891C0"/>
+                </a:solidFill>
+                <a:latin typeface="Calibri" pitchFamily="34" charset="0"/>
+                <a:ea typeface="Calibri" pitchFamily="34" charset="-122"/>
+                <a:cs typeface="Calibri" pitchFamily="34" charset="-120"/>
+              </a:rPr>
+              <a:t>kubectl get nodes on prod, run through az aks command invoke: 3 system and 2 user nodes, all Ready</a:t>
+            </a:r>
+            <a:endParaRPr lang="en-US" sz="950" dirty="0"/>
+          </a:p>
+        </p:txBody>
+      </p:sp>
+      <p:pic>
+        <p:nvPicPr>
+          <p:cNvPr id="26" name="Image 2" descr="/tmp/claude-1000/-home-sufideen--config-Claude-scratch-workspaces-3637d91f-12c3-4b41-8698-1a9b1c090587-8dbdcacd-85cb-4266-9c51-29022c3bf154-scratch-2026-09-19-0422a7/b88270b6-1dec-4e78-9e04-de6497b56a14/scratchpad/pub/az-ent-sec-dashboard/scripts/slide-deck/assets/resource-groups-crop.png">    </p:cNvPr>
+          <p:cNvPicPr>
+            <a:picLocks noChangeAspect="1"/>
+          </p:cNvPicPr>
+          <p:nvPr/>
+        </p:nvPicPr>
+        <p:blipFill>
+          <a:blip r:embed="rId3"/>
+          <a:stretch>
+            <a:fillRect/>
+          </a:stretch>
+        </p:blipFill>
+        <p:spPr>
+          <a:xfrm>
+            <a:off x="548640" y="4846320"/>
+            <a:ext cx="4572000" cy="960504"/>
+          </a:xfrm>
+          <a:prstGeom prst="rect">
+            <a:avLst/>
+          </a:prstGeom>
+        </p:spPr>
+      </p:pic>
+      <p:sp>
+        <p:nvSpPr>
+          <p:cNvPr id="27" name="Text 22"/>
+          <p:cNvSpPr txBox="1"/>
+          <p:nvPr/>
+        </p:nvSpPr>
+        <p:spPr>
+          <a:xfrm>
+            <a:off x="5257800" y="5029200"/>
+            <a:ext cx="2514600" cy="685800"/>
+          </a:xfrm>
+          <a:prstGeom prst="rect">
+            <a:avLst/>
+          </a:prstGeom>
+          <a:noFill/>
+          <a:ln/>
+        </p:spPr>
+        <p:txBody>
+          <a:bodyPr wrap="square" rtlCol="0" anchor="t"/>
+          <a:lstStyle/>
+          <a:p>
+            <a:pPr indent="0" marL="0">
+              <a:buNone/>
+            </a:pPr>
+            <a:r>
+              <a:rPr lang="en-US" sz="950" i="1" dirty="0">
+                <a:solidFill>
+                  <a:srgbClr val="8891C0"/>
+                </a:solidFill>
+                <a:latin typeface="Calibri" pitchFamily="34" charset="0"/>
+                <a:ea typeface="Calibri" pitchFamily="34" charset="-122"/>
+                <a:cs typeface="Calibri" pitchFamily="34" charset="-120"/>
+              </a:rPr>
+              <a:t>Azure portal: dev and prod resource groups, plus the AKS-managed node groups</a:t>
+            </a:r>
+            <a:endParaRPr lang="en-US" sz="950" dirty="0"/>
+          </a:p>
+        </p:txBody>
+      </p:sp>
+      <p:sp>
+        <p:nvSpPr>
+          <p:cNvPr id="28" name="Shape 23"/>
           <p:cNvSpPr/>
           <p:nvPr/>
         </p:nvSpPr>
         <p:spPr>
           <a:xfrm>
-            <a:off x="548640" y="3703320"/>
-            <a:ext cx="11091672" cy="1600200"/>
+            <a:off x="8092440" y="3520440"/>
+            <a:ext cx="3547872" cy="2286000"/>
           </a:xfrm>
           <a:prstGeom prst="roundRect">
             <a:avLst>
-              <a:gd name="adj" fmla="val 5714"/>
+              <a:gd name="adj" fmla="val 4000"/>
             </a:avLst>
           </a:prstGeom>
           <a:solidFill>
@@ -2875,14 +3001,14 @@
       </p:sp>
       <p:sp>
         <p:nvSpPr>
-          <p:cNvPr id="25" name="Text 22"/>
-          <p:cNvSpPr txBox="1"/>
-          <p:nvPr/>
-        </p:nvSpPr>
-        <p:spPr>
-          <a:xfrm>
-            <a:off x="868680" y="3886200"/>
-            <a:ext cx="7315200" cy="365760"/>
+          <p:cNvPr id="29" name="Text 24"/>
+          <p:cNvSpPr txBox="1"/>
+          <p:nvPr/>
+        </p:nvSpPr>
+        <p:spPr>
+          <a:xfrm>
+            <a:off x="8321040" y="3657600"/>
+            <a:ext cx="3108960" cy="365760"/>
           </a:xfrm>
           <a:prstGeom prst="rect">
             <a:avLst/>
@@ -2906,7 +3032,7 @@
                 <a:ea typeface="Calibri" pitchFamily="34" charset="-122"/>
                 <a:cs typeface="Calibri" pitchFamily="34" charset="-120"/>
               </a:rPr>
-              <a:t>12 pieces of evidence in the repo</a:t>
+              <a:t>What I'd point out</a:t>
             </a:r>
             <a:endParaRPr lang="en-US" sz="1300" dirty="0"/>
           </a:p>
@@ -2914,14 +3040,14 @@
       </p:sp>
       <p:sp>
         <p:nvSpPr>
-          <p:cNvPr id="26" name="Text 23"/>
-          <p:cNvSpPr txBox="1"/>
-          <p:nvPr/>
-        </p:nvSpPr>
-        <p:spPr>
-          <a:xfrm>
-            <a:off x="868680" y="4251960"/>
-            <a:ext cx="10424160" cy="914400"/>
+          <p:cNvPr id="30" name="Text 25"/>
+          <p:cNvSpPr txBox="1"/>
+          <p:nvPr/>
+        </p:nvSpPr>
+        <p:spPr>
+          <a:xfrm>
+            <a:off x="8321040" y="4023360"/>
+            <a:ext cx="3108960" cy="1691640"/>
           </a:xfrm>
           <a:prstGeom prst="rect">
             <a:avLst/>
@@ -2935,12 +3061,12 @@
           <a:p>
             <a:pPr indent="0" marL="0">
               <a:lnSpc>
-                <a:spcPct val="130000"/>
+                <a:spcPct val="125000"/>
               </a:lnSpc>
               <a:buNone/>
             </a:pPr>
             <a:r>
-              <a:rPr lang="en-US" sz="1100" dirty="0">
+              <a:rPr lang="en-US" sz="1050" dirty="0">
                 <a:solidFill>
                   <a:srgbClr val="CADCFC"/>
                 </a:solidFill>
@@ -2948,15 +3074,15 @@
                 <a:ea typeface="Calibri" pitchFamily="34" charset="-122"/>
                 <a:cs typeface="Calibri" pitchFamily="34" charset="-120"/>
               </a:rPr>
-              <a:t>Resource groups · node pool health · private DNS zone · kubectl get nodes · pods running · backend health · end-to-end curl · cluster overview · Defender inventory — across both dev and prod, screenshots and raw command output alike.</a:t>
-            </a:r>
-            <a:endParaRPr lang="en-US" sz="1100" dirty="0"/>
-          </a:p>
-        </p:txBody>
-      </p:sp>
-      <p:sp>
-        <p:nvSpPr>
-          <p:cNvPr id="27" name="Text 24"/>
+              <a:t>Both environments are live and separate. Twelve pieces of evidence are in the repo: node health, private DNS, pods, backend health, end-to-end curl and Defender inventory, for dev and prod.</a:t>
+            </a:r>
+            <a:endParaRPr lang="en-US" sz="1050" dirty="0"/>
+          </a:p>
+        </p:txBody>
+      </p:sp>
+      <p:sp>
+        <p:nvSpPr>
+          <p:cNvPr id="32" name="Text 26"/>
           <p:cNvSpPr/>
           <p:nvPr/>
         </p:nvSpPr>
@@ -2995,7 +3121,7 @@
       </p:sp>
       <p:sp>
         <p:nvSpPr>
-          <p:cNvPr id="28" name="Text 25"/>
+          <p:cNvPr id="33" name="Text 27"/>
           <p:cNvSpPr/>
           <p:nvPr/>
         </p:nvSpPr>
@@ -3387,7 +3513,7 @@
                 <a:ea typeface="Calibri" pitchFamily="34" charset="-122"/>
                 <a:cs typeface="Calibri" pitchFamily="34" charset="-120"/>
               </a:rPr>
-              <a:t>Full technical write-up, evidence, and runbook in the repository's docs/ folder</a:t>
+              <a:t>The full write-up, evidence and runbook are in the docs/ folder of the repository</a:t>
             </a:r>
             <a:endParaRPr lang="en-US" sz="1050" dirty="0"/>
           </a:p>
@@ -3458,7 +3584,7 @@
                 <a:ea typeface="Cambria" pitchFamily="34" charset="-122"/>
                 <a:cs typeface="Cambria" pitchFamily="34" charset="-120"/>
               </a:rPr>
-              <a:t>What This Is</a:t>
+              <a:t>What I Built</a:t>
             </a:r>
             <a:endParaRPr lang="en-US" sz="3200" dirty="0"/>
           </a:p>
@@ -3500,7 +3626,7 @@
                 <a:ea typeface="Calibri" pitchFamily="34" charset="-122"/>
                 <a:cs typeface="Calibri" pitchFamily="34" charset="-120"/>
               </a:rPr>
-              <a:t>A containerized web application running on a private Azure Kubernetes Service cluster, fronted by a WAF-enabled Application Gateway, backed by a private container registry, deployed through OIDC-authenticated GitHub Actions CI/CD — with zero long-lived credentials anywhere in the pipeline.</a:t>
+              <a:t>I built a containerized web application on a private Azure Kubernetes Service cluster. It sits behind a WAF-enabled Application Gateway, pulls images from a private container registry, and is deployed by GitHub Actions using OIDC, so there are no long-lived credentials anywhere in the pipeline.</a:t>
             </a:r>
             <a:endParaRPr lang="en-US" sz="1450" dirty="0"/>
           </a:p>
@@ -4235,7 +4361,7 @@
                 <a:ea typeface="Calibri" pitchFamily="34" charset="-122"/>
                 <a:cs typeface="Calibri" pitchFamily="34" charset="-120"/>
               </a:rPr>
-              <a:t>Both environments verified end-to-end as of 2026-09-18 — real pods, real TLS, real public IP, real HTTP 200.</a:t>
+              <a:t>I verified both environments end to end on 2026-09-18: real pods, real TLS, a real public IP and a real HTTP 200.</a:t>
             </a:r>
             <a:endParaRPr lang="en-US" sz="1250" dirty="0"/>
           </a:p>
@@ -4243,7 +4369,7 @@
       </p:sp>
       <p:sp>
         <p:nvSpPr>
-          <p:cNvPr id="25" name="Text 19"/>
+          <p:cNvPr id="26" name="Text 19"/>
           <p:cNvSpPr/>
           <p:nvPr/>
         </p:nvSpPr>
@@ -4282,7 +4408,7 @@
       </p:sp>
       <p:sp>
         <p:nvSpPr>
-          <p:cNvPr id="26" name="Text 20"/>
+          <p:cNvPr id="27" name="Text 20"/>
           <p:cNvSpPr/>
           <p:nvPr/>
         </p:nvSpPr>
@@ -4360,7 +4486,7 @@
         <p:spPr>
           <a:xfrm>
             <a:off x="548640" y="320040"/>
-            <a:ext cx="7315200" cy="548640"/>
+            <a:ext cx="9144000" cy="548640"/>
           </a:xfrm>
           <a:prstGeom prst="rect">
             <a:avLst/>
@@ -4384,7 +4510,7 @@
                 <a:ea typeface="Cambria" pitchFamily="34" charset="-122"/>
                 <a:cs typeface="Cambria" pitchFamily="34" charset="-120"/>
               </a:rPr>
-              <a:t>Architecture</a:t>
+              <a:t>Architecture: how a request travels</a:t>
             </a:r>
             <a:endParaRPr lang="en-US" sz="3000" dirty="0"/>
           </a:p>
@@ -4650,7 +4776,7 @@
         <p:spPr>
           <a:xfrm>
             <a:off x="6094476" y="2834640"/>
-            <a:ext cx="0" cy="365760"/>
+            <a:ext cx="0" cy="320040"/>
           </a:xfrm>
           <a:prstGeom prst="line">
             <a:avLst/>
@@ -4712,12 +4838,12 @@
         </p:nvSpPr>
         <p:spPr>
           <a:xfrm>
-            <a:off x="1280160" y="3200400"/>
-            <a:ext cx="9628632" cy="2606040"/>
+            <a:off x="1280160" y="3154680"/>
+            <a:ext cx="9628632" cy="2148840"/>
           </a:xfrm>
           <a:prstGeom prst="roundRect">
             <a:avLst>
-              <a:gd name="adj" fmla="val 3509"/>
+              <a:gd name="adj" fmla="val 4255"/>
             </a:avLst>
           </a:prstGeom>
           <a:solidFill>
@@ -4739,7 +4865,7 @@
         </p:nvSpPr>
         <p:spPr>
           <a:xfrm>
-            <a:off x="1463040" y="3310128"/>
+            <a:off x="1463040" y="3264408"/>
             <a:ext cx="9262872" cy="320040"/>
           </a:xfrm>
           <a:prstGeom prst="rect">
@@ -4778,12 +4904,12 @@
         </p:nvSpPr>
         <p:spPr>
           <a:xfrm>
-            <a:off x="1920240" y="3794760"/>
-            <a:ext cx="3291840" cy="1737360"/>
+            <a:off x="1920240" y="3703320"/>
+            <a:ext cx="3291840" cy="1417320"/>
           </a:xfrm>
           <a:prstGeom prst="roundRect">
             <a:avLst>
-              <a:gd name="adj" fmla="val 4211"/>
+              <a:gd name="adj" fmla="val 5161"/>
             </a:avLst>
           </a:prstGeom>
           <a:solidFill>
@@ -4805,7 +4931,7 @@
         </p:nvSpPr>
         <p:spPr>
           <a:xfrm>
-            <a:off x="2103120" y="3977640"/>
+            <a:off x="2103120" y="3886200"/>
             <a:ext cx="502920" cy="502920"/>
           </a:xfrm>
           <a:prstGeom prst="ellipse">
@@ -4833,7 +4959,7 @@
         </p:blipFill>
         <p:spPr>
           <a:xfrm>
-            <a:off x="2216277" y="4090797"/>
+            <a:off x="2216277" y="3999357"/>
             <a:ext cx="276606" cy="276606"/>
           </a:xfrm>
           <a:prstGeom prst="rect">
@@ -4849,7 +4975,7 @@
         </p:nvSpPr>
         <p:spPr>
           <a:xfrm>
-            <a:off x="2743200" y="3995928"/>
+            <a:off x="2743200" y="3904488"/>
             <a:ext cx="2286000" cy="274320"/>
           </a:xfrm>
           <a:prstGeom prst="rect">
@@ -4888,8 +5014,8 @@
         </p:nvSpPr>
         <p:spPr>
           <a:xfrm>
-            <a:off x="2103120" y="4572000"/>
-            <a:ext cx="2834640" cy="822960"/>
+            <a:off x="2103120" y="4480560"/>
+            <a:ext cx="2834640" cy="548640"/>
           </a:xfrm>
           <a:prstGeom prst="rect">
             <a:avLst/>
@@ -4950,12 +5076,12 @@
         </p:nvSpPr>
         <p:spPr>
           <a:xfrm>
-            <a:off x="5715000" y="3794760"/>
-            <a:ext cx="3291840" cy="1737360"/>
+            <a:off x="5715000" y="3703320"/>
+            <a:ext cx="3291840" cy="1417320"/>
           </a:xfrm>
           <a:prstGeom prst="roundRect">
             <a:avLst>
-              <a:gd name="adj" fmla="val 4211"/>
+              <a:gd name="adj" fmla="val 5161"/>
             </a:avLst>
           </a:prstGeom>
           <a:solidFill>
@@ -4977,7 +5103,7 @@
         </p:nvSpPr>
         <p:spPr>
           <a:xfrm>
-            <a:off x="5897880" y="3977640"/>
+            <a:off x="5897880" y="3886200"/>
             <a:ext cx="502920" cy="502920"/>
           </a:xfrm>
           <a:prstGeom prst="ellipse">
@@ -5005,7 +5131,7 @@
         </p:blipFill>
         <p:spPr>
           <a:xfrm>
-            <a:off x="6011037" y="4090797"/>
+            <a:off x="6011037" y="3999357"/>
             <a:ext cx="276606" cy="276606"/>
           </a:xfrm>
           <a:prstGeom prst="rect">
@@ -5021,7 +5147,7 @@
         </p:nvSpPr>
         <p:spPr>
           <a:xfrm>
-            <a:off x="6537960" y="3995928"/>
+            <a:off x="6537960" y="3904488"/>
             <a:ext cx="2377440" cy="274320"/>
           </a:xfrm>
           <a:prstGeom prst="rect">
@@ -5060,8 +5186,8 @@
         </p:nvSpPr>
         <p:spPr>
           <a:xfrm>
-            <a:off x="5897880" y="4572000"/>
-            <a:ext cx="2834640" cy="822960"/>
+            <a:off x="5897880" y="4480560"/>
+            <a:ext cx="2834640" cy="548640"/>
           </a:xfrm>
           <a:prstGeom prst="rect">
             <a:avLst/>
@@ -5122,8 +5248,8 @@
         </p:nvSpPr>
         <p:spPr>
           <a:xfrm>
-            <a:off x="2414016" y="5532120"/>
-            <a:ext cx="1760220" cy="594360"/>
+            <a:off x="2414016" y="5120640"/>
+            <a:ext cx="1760220" cy="411480"/>
           </a:xfrm>
           <a:prstGeom prst="line">
             <a:avLst/>
@@ -5146,8 +5272,8 @@
         </p:nvSpPr>
         <p:spPr>
           <a:xfrm>
-            <a:off x="8513064" y="5532120"/>
-            <a:ext cx="-498348" cy="594360"/>
+            <a:off x="8513064" y="5120640"/>
+            <a:ext cx="-498348" cy="411480"/>
           </a:xfrm>
           <a:prstGeom prst="line">
             <a:avLst/>
@@ -5170,12 +5296,12 @@
         </p:nvSpPr>
         <p:spPr>
           <a:xfrm>
-            <a:off x="2619756" y="6126480"/>
-            <a:ext cx="3108960" cy="960120"/>
+            <a:off x="2619756" y="5532120"/>
+            <a:ext cx="3108960" cy="868680"/>
           </a:xfrm>
           <a:prstGeom prst="roundRect">
             <a:avLst>
-              <a:gd name="adj" fmla="val 7619"/>
+              <a:gd name="adj" fmla="val 8421"/>
             </a:avLst>
           </a:prstGeom>
           <a:solidFill>
@@ -5192,7 +5318,7 @@
         </p:nvSpPr>
         <p:spPr>
           <a:xfrm>
-            <a:off x="2784348" y="6327648"/>
+            <a:off x="2784348" y="5733288"/>
             <a:ext cx="548640" cy="548640"/>
           </a:xfrm>
           <a:prstGeom prst="ellipse">
@@ -5220,7 +5346,7 @@
         </p:blipFill>
         <p:spPr>
           <a:xfrm>
-            <a:off x="2907792" y="6451092"/>
+            <a:off x="2907792" y="5856732"/>
             <a:ext cx="301752" cy="301752"/>
           </a:xfrm>
           <a:prstGeom prst="rect">
@@ -5236,7 +5362,7 @@
         </p:nvSpPr>
         <p:spPr>
           <a:xfrm>
-            <a:off x="3488436" y="6254496"/>
+            <a:off x="3488436" y="5660136"/>
             <a:ext cx="2103120" cy="274320"/>
           </a:xfrm>
           <a:prstGeom prst="rect">
@@ -5275,7 +5401,7 @@
         </p:nvSpPr>
         <p:spPr>
           <a:xfrm>
-            <a:off x="3488436" y="6547104"/>
+            <a:off x="3488436" y="5952744"/>
             <a:ext cx="2103120" cy="502920"/>
           </a:xfrm>
           <a:prstGeom prst="rect">
@@ -5337,12 +5463,12 @@
         </p:nvSpPr>
         <p:spPr>
           <a:xfrm>
-            <a:off x="6460236" y="6126480"/>
-            <a:ext cx="3108960" cy="960120"/>
+            <a:off x="6460236" y="5532120"/>
+            <a:ext cx="3108960" cy="868680"/>
           </a:xfrm>
           <a:prstGeom prst="roundRect">
             <a:avLst>
-              <a:gd name="adj" fmla="val 7619"/>
+              <a:gd name="adj" fmla="val 8421"/>
             </a:avLst>
           </a:prstGeom>
           <a:solidFill>
@@ -5359,7 +5485,7 @@
         </p:nvSpPr>
         <p:spPr>
           <a:xfrm>
-            <a:off x="6624828" y="6327648"/>
+            <a:off x="6624828" y="5733288"/>
             <a:ext cx="548640" cy="548640"/>
           </a:xfrm>
           <a:prstGeom prst="ellipse">
@@ -5387,7 +5513,7 @@
         </p:blipFill>
         <p:spPr>
           <a:xfrm>
-            <a:off x="6748272" y="6451092"/>
+            <a:off x="6748272" y="5856732"/>
             <a:ext cx="301752" cy="301752"/>
           </a:xfrm>
           <a:prstGeom prst="rect">
@@ -5403,7 +5529,7 @@
         </p:nvSpPr>
         <p:spPr>
           <a:xfrm>
-            <a:off x="7328916" y="6254496"/>
+            <a:off x="7328916" y="5660136"/>
             <a:ext cx="2103120" cy="274320"/>
           </a:xfrm>
           <a:prstGeom prst="rect">
@@ -5442,7 +5568,7 @@
         </p:nvSpPr>
         <p:spPr>
           <a:xfrm>
-            <a:off x="7328916" y="6547104"/>
+            <a:off x="7328916" y="5952744"/>
             <a:ext cx="2103120" cy="502920"/>
           </a:xfrm>
           <a:prstGeom prst="rect">
@@ -5498,7 +5624,7 @@
       </p:sp>
       <p:sp>
         <p:nvSpPr>
-          <p:cNvPr id="38" name="Text 30"/>
+          <p:cNvPr id="39" name="Text 30"/>
           <p:cNvSpPr/>
           <p:nvPr/>
         </p:nvSpPr>
@@ -5537,7 +5663,7 @@
       </p:sp>
       <p:sp>
         <p:nvSpPr>
-          <p:cNvPr id="39" name="Text 31"/>
+          <p:cNvPr id="40" name="Text 31"/>
           <p:cNvSpPr/>
           <p:nvPr/>
         </p:nvSpPr>
@@ -5678,7 +5804,7 @@
                 <a:ea typeface="Calibri" pitchFamily="34" charset="-122"/>
                 <a:cs typeface="Calibri" pitchFamily="34" charset="-120"/>
               </a:rPr>
-              <a:t>Real Kubernetes objects, mapped to what they actually do here</a:t>
+              <a:t>The Kubernetes objects I deployed, and what each one does for me</a:t>
             </a:r>
             <a:endParaRPr lang="en-US" sz="1300" dirty="0"/>
           </a:p>
@@ -6600,7 +6726,7 @@
       </p:sp>
       <p:sp>
         <p:nvSpPr>
-          <p:cNvPr id="35" name="Text 26"/>
+          <p:cNvPr id="36" name="Text 26"/>
           <p:cNvSpPr/>
           <p:nvPr/>
         </p:nvSpPr>
@@ -6639,7 +6765,7 @@
       </p:sp>
       <p:sp>
         <p:nvSpPr>
-          <p:cNvPr id="36" name="Text 27"/>
+          <p:cNvPr id="37" name="Text 27"/>
           <p:cNvSpPr/>
           <p:nvPr/>
         </p:nvSpPr>
@@ -6741,7 +6867,7 @@
                 <a:ea typeface="Cambria" pitchFamily="34" charset="-122"/>
                 <a:cs typeface="Cambria" pitchFamily="34" charset="-120"/>
               </a:rPr>
-              <a:t>Security by Design</a:t>
+              <a:t>How I Locked It Down</a:t>
             </a:r>
             <a:endParaRPr lang="en-US" sz="3000" dirty="0"/>
           </a:p>
@@ -7649,7 +7775,7 @@
       </p:sp>
       <p:sp>
         <p:nvSpPr>
-          <p:cNvPr id="33" name="Text 25"/>
+          <p:cNvPr id="34" name="Text 25"/>
           <p:cNvSpPr/>
           <p:nvPr/>
         </p:nvSpPr>
@@ -7688,7 +7814,7 @@
       </p:sp>
       <p:sp>
         <p:nvSpPr>
-          <p:cNvPr id="34" name="Text 26"/>
+          <p:cNvPr id="35" name="Text 26"/>
           <p:cNvSpPr/>
           <p:nvPr/>
         </p:nvSpPr>
@@ -8990,7 +9116,7 @@
                 <a:ea typeface="Calibri" pitchFamily="34" charset="-122"/>
                 <a:cs typeface="Calibri" pitchFamily="34" charset="-120"/>
               </a:rPr>
-              <a:t>Why this matters: a GitHub-hosted runner has no network line-of-sight into the cluster at all. “command invoke” executes kubectl inside the cluster's own control plane — zero VPN, self-hosted runner, or Bastion host required.</a:t>
+              <a:t>Why I built it this way: a GitHub-hosted runner has no network route into a private cluster. So I use “az aks command invoke”, which runs kubectl through Azure itself. No VPN, no self-hosted runner and no Bastion host.</a:t>
             </a:r>
             <a:endParaRPr lang="en-US" sz="1200" dirty="0"/>
           </a:p>
@@ -8998,7 +9124,7 @@
       </p:sp>
       <p:sp>
         <p:nvSpPr>
-          <p:cNvPr id="34" name="Text 27"/>
+          <p:cNvPr id="35" name="Text 27"/>
           <p:cNvSpPr/>
           <p:nvPr/>
         </p:nvSpPr>
@@ -9037,7 +9163,7 @@
       </p:sp>
       <p:sp>
         <p:nvSpPr>
-          <p:cNvPr id="35" name="Text 28"/>
+          <p:cNvPr id="36" name="Text 28"/>
           <p:cNvSpPr/>
           <p:nvPr/>
         </p:nvSpPr>
@@ -9183,7 +9309,7 @@
                 <a:ea typeface="Cambria" pitchFamily="34" charset="-122"/>
                 <a:cs typeface="Cambria" pitchFamily="34" charset="-120"/>
               </a:rPr>
-              <a:t>A Real Incident, Not a Demo</a:t>
+              <a:t>The Day Prod Broke</a:t>
             </a:r>
             <a:endParaRPr lang="en-US" sz="2800" dirty="0"/>
           </a:p>
@@ -9222,7 +9348,7 @@
                 <a:ea typeface="Calibri" pitchFamily="34" charset="-122"/>
                 <a:cs typeface="Calibri" pitchFamily="34" charset="-120"/>
               </a:rPr>
-              <a:t>Prod's app sat in ContainerCreating for 24+ hours, undetected — diagnosed and fixed live, five layers deep.</a:t>
+              <a:t>My prod app sat in ContainerCreating for over 24 hours and I hadn't noticed. Here is how I found it, five layers deep.</a:t>
             </a:r>
             <a:endParaRPr lang="en-US" sz="1300" dirty="0"/>
           </a:p>
@@ -9979,7 +10105,7 @@
       </p:sp>
       <p:sp>
         <p:nvSpPr>
-          <p:cNvPr id="27" name="Text 24"/>
+          <p:cNvPr id="28" name="Text 24"/>
           <p:cNvSpPr/>
           <p:nvPr/>
         </p:nvSpPr>
@@ -10018,7 +10144,7 @@
       </p:sp>
       <p:sp>
         <p:nvSpPr>
-          <p:cNvPr id="28" name="Text 25"/>
+          <p:cNvPr id="29" name="Text 25"/>
           <p:cNvSpPr/>
           <p:nvPr/>
         </p:nvSpPr>
@@ -10120,7 +10246,7 @@
                 <a:ea typeface="Cambria" pitchFamily="34" charset="-122"/>
                 <a:cs typeface="Cambria" pitchFamily="34" charset="-120"/>
               </a:rPr>
-              <a:t>Kubernetes, Explained</a:t>
+              <a:t>Kubernetes in Plain Language</a:t>
             </a:r>
             <a:endParaRPr lang="en-US" sz="3000" dirty="0"/>
           </a:p>
@@ -10159,7 +10285,7 @@
                 <a:ea typeface="Calibri" pitchFamily="34" charset="-122"/>
                 <a:cs typeface="Calibri" pitchFamily="34" charset="-120"/>
               </a:rPr>
-              <a:t>Key terms, in plain language, in the context of this project</a:t>
+              <a:t>The terms I'll use today, explained the way I use them in this project</a:t>
             </a:r>
             <a:endParaRPr lang="en-US" sz="1300" dirty="0"/>
           </a:p>
@@ -10977,7 +11103,7 @@
       </p:sp>
       <p:sp>
         <p:nvSpPr>
-          <p:cNvPr id="24" name="Text 22"/>
+          <p:cNvPr id="25" name="Text 22"/>
           <p:cNvSpPr/>
           <p:nvPr/>
         </p:nvSpPr>
@@ -11016,7 +11142,7 @@
       </p:sp>
       <p:sp>
         <p:nvSpPr>
-          <p:cNvPr id="25" name="Text 23"/>
+          <p:cNvPr id="26" name="Text 23"/>
           <p:cNvSpPr/>
           <p:nvPr/>
         </p:nvSpPr>
@@ -11118,7 +11244,7 @@
                 <a:ea typeface="Cambria" pitchFamily="34" charset="-122"/>
                 <a:cs typeface="Cambria" pitchFamily="34" charset="-120"/>
               </a:rPr>
-              <a:t>Where This Pattern Fits</a:t>
+              <a:t>Where I'd Use This Pattern</a:t>
             </a:r>
             <a:endParaRPr lang="en-US" sz="3000" dirty="0"/>
           </a:p>
@@ -11754,7 +11880,7 @@
       </p:sp>
       <p:sp>
         <p:nvSpPr>
-          <p:cNvPr id="23" name="Text 17"/>
+          <p:cNvPr id="24" name="Text 17"/>
           <p:cNvSpPr/>
           <p:nvPr/>
         </p:nvSpPr>
@@ -11793,7 +11919,7 @@
       </p:sp>
       <p:sp>
         <p:nvSpPr>
-          <p:cNvPr id="24" name="Text 18"/>
+          <p:cNvPr id="25" name="Text 18"/>
           <p:cNvSpPr/>
           <p:nvPr/>
         </p:nvSpPr>

</xml_diff>

<commit_message>
feat(webplat): add a plain-English connectivity diagram for non-technical viewers
Adds a self-explanatory SVG (visitor journey through the guarded gateway
into the private vault, plus the passwordless OIDC delivery path) using
plain-language metaphors instead of Azure/Kubernetes terminology.

- New "The plain-English version" section on the live Architecture page,
  above the existing technical diagram, in a light card against the
  site's dark theme.
- New slide 3 in the showcase deck (renumbering the incident/closing
  slides), so the same diagram carries into the 5-minute demo.

Co-Authored-By: Claude Sonnet 5 <noreply@anthropic.com>
Claude-Session: https://claude.ai/code/session_01CPhKDrJQ9Gz72BkkJG44w4
</commit_message>
<xml_diff>
--- a/docs/webplat-kubernetes-showcase.pptx
+++ b/docs/webplat-kubernetes-showcase.pptx
@@ -9,9 +9,10 @@
     <p:sldId id="257" r:id="rId3"/>
     <p:sldId id="258" r:id="rId4"/>
     <p:sldId id="259" r:id="rId5"/>
+    <p:sldId id="260" r:id="rId6"/>
   </p:sldIdLst>
   <p:notesMasterIdLst>
-    <p:notesMasterId r:id="rId6"/>
+    <p:notesMasterId r:id="rId7"/>
   </p:notesMasterIdLst>
   <p:sldSz cx="12192000" cy="6858000"/>
   <p:notesSz cx="6858000" cy="12192000"/>
@@ -681,7 +682,7 @@
           <a:p>
             <a:r>
               <a:rPr lang="en-US" dirty="0"/>
-              <a:t>This is the slide I'm most glad to show. None of this is hypothetical — I tore this environment down myself a few hours ago and rebuilt it live, and each of these five things broke in turn, each one hiding the next. What I took from it: resource-group deletion doesn't just delete resources, it silently deletes every RBAC grant and cached identity pointing at them, and that's worth writing into the runbook.</a:t>
+              <a:t>For anyone in the room who isn't deep into Kubernetes, here's the same design in plain language. A visitor's traffic travels over a locked connection, past a guarded front door that blocks attacks, into a vault with no public entrance. Separately, updates are delivered using a temporary digital ID that expires in minutes — never a stored password. Same system as the last slide, just described for a general audience.</a:t>
             </a:r>
             <a:endParaRPr lang="en-US" dirty="0"/>
           </a:p>
@@ -769,7 +770,7 @@
           <a:p>
             <a:r>
               <a:rPr lang="en-US" dirty="0"/>
-              <a:t>To sum up: I can design a private, zero-secret Kubernetes platform on Azure, automate its delivery, and when a full environment teardown breaks five things at once, work through it methodically and get it back to a trusted, verified state. Happy to take questions, or go deeper on any part of this live.</a:t>
+              <a:t>This is the slide I'm most glad to show. None of this is hypothetical — I tore this environment down myself a few hours ago and rebuilt it live, and each of these five things broke in turn, each one hiding the next. What I took from it: resource-group deletion doesn't just delete resources, it silently deletes every RBAC grant and cached identity pointing at them, and that's worth writing into the runbook.</a:t>
             </a:r>
             <a:endParaRPr lang="en-US" dirty="0"/>
           </a:p>
@@ -793,6 +794,94 @@
             <a:fld id="{F7021451-1387-4CA6-816F-3879F97B5CBC}" type="slidenum">
               <a:rPr lang="en-US"/>
               <a:t>4</a:t>
+            </a:fld>
+            <a:endParaRPr lang="en-US"/>
+          </a:p>
+        </p:txBody>
+      </p:sp>
+    </p:spTree>
+    <p:extLst>
+      <p:ext uri="{BB962C8B-B14F-4D97-AF65-F5344CB8AC3E}">
+        <p14:creationId xmlns:p14="http://schemas.microsoft.com/office/powerpoint/2010/main" val="1024086991"/>
+      </p:ext>
+    </p:extLst>
+  </p:cSld>
+  <p:clrMapOvr>
+    <a:masterClrMapping/>
+  </p:clrMapOvr>
+</p:notes>
+</file>
+
+<file path=ppt/notesSlides/notesSlide5.xml><?xml version="1.0" encoding="utf-8"?>
+<p:notes xmlns:a="http://schemas.openxmlformats.org/drawingml/2006/main" xmlns:r="http://schemas.openxmlformats.org/officeDocument/2006/relationships" xmlns:p="http://schemas.openxmlformats.org/presentationml/2006/main">
+  <p:cSld>
+    <p:spTree>
+      <p:nvGrpSpPr>
+        <p:cNvPr id="1" name=""/>
+        <p:cNvGrpSpPr/>
+        <p:nvPr/>
+      </p:nvGrpSpPr>
+      <p:grpSpPr>
+        <a:xfrm>
+          <a:off x="0" y="0"/>
+          <a:ext cx="0" cy="0"/>
+          <a:chOff x="0" y="0"/>
+          <a:chExt cx="0" cy="0"/>
+        </a:xfrm>
+      </p:grpSpPr>
+      <p:sp>
+        <p:nvSpPr>
+          <p:cNvPr id="2" name="Slide Image Placeholder 1"/>
+          <p:cNvSpPr>
+            <a:spLocks noGrp="1" noRot="1" noChangeAspect="1"/>
+          </p:cNvSpPr>
+          <p:nvPr>
+            <p:ph type="sldImg"/>
+          </p:nvPr>
+        </p:nvSpPr>
+        <p:spPr/>
+      </p:sp>
+      <p:sp>
+        <p:nvSpPr>
+          <p:cNvPr id="3" name="Notes Placeholder 2"/>
+          <p:cNvSpPr>
+            <a:spLocks noGrp="1"/>
+          </p:cNvSpPr>
+          <p:nvPr>
+            <p:ph type="body" idx="1"/>
+          </p:nvPr>
+        </p:nvSpPr>
+        <p:spPr/>
+        <p:txBody>
+          <a:bodyPr/>
+          <a:lstStyle/>
+          <a:p>
+            <a:r>
+              <a:rPr lang="en-US" dirty="0"/>
+              <a:t>To sum up: I can design a private, zero-secret Kubernetes platform on Azure, automate its delivery, and when a full environment teardown breaks five things at once, work through it methodically and get it back to a trusted, verified state. Happy to take questions, or go deeper on any part of this live.</a:t>
+            </a:r>
+            <a:endParaRPr lang="en-US" dirty="0"/>
+          </a:p>
+        </p:txBody>
+      </p:sp>
+      <p:sp>
+        <p:nvSpPr>
+          <p:cNvPr id="4" name="Slide Number Placeholder 3"/>
+          <p:cNvSpPr>
+            <a:spLocks noGrp="1"/>
+          </p:cNvSpPr>
+          <p:nvPr>
+            <p:ph type="sldNum" sz="quarter" idx="10"/>
+          </p:nvPr>
+        </p:nvSpPr>
+        <p:spPr/>
+        <p:txBody>
+          <a:bodyPr/>
+          <a:lstStyle/>
+          <a:p>
+            <a:fld id="{F7021451-1387-4CA6-816F-3879F97B5CBC}" type="slidenum">
+              <a:rPr lang="en-US"/>
+              <a:t>5</a:t>
             </a:fld>
             <a:endParaRPr lang="en-US"/>
           </a:p>
@@ -2332,6 +2421,140 @@
     <p:bg>
       <p:bgPr>
         <a:solidFill>
+          <a:srgbClr val="FFFFFF"/>
+        </a:solidFill>
+      </p:bgPr>
+    </p:bg>
+    <p:spTree>
+      <p:nvGrpSpPr>
+        <p:cNvPr id="1" name=""/>
+        <p:cNvGrpSpPr/>
+        <p:nvPr/>
+      </p:nvGrpSpPr>
+      <p:grpSpPr>
+        <a:xfrm>
+          <a:off x="0" y="0"/>
+          <a:ext cx="0" cy="0"/>
+          <a:chOff x="0" y="0"/>
+          <a:chExt cx="0" cy="0"/>
+        </a:xfrm>
+      </p:grpSpPr>
+      <p:pic>
+        <p:nvPicPr>
+          <p:cNvPr id="2" name="Image 0" descr="/home/user/az-ent-sec-dashboard/scripts/slide-deck/assets/plain-english-connectivity.png">    </p:cNvPr>
+          <p:cNvPicPr>
+            <a:picLocks noChangeAspect="1"/>
+          </p:cNvPicPr>
+          <p:nvPr/>
+        </p:nvPicPr>
+        <p:blipFill>
+          <a:blip r:embed="rId1"/>
+          <a:stretch>
+            <a:fillRect/>
+          </a:stretch>
+        </p:blipFill>
+        <p:spPr>
+          <a:xfrm>
+            <a:off x="685800" y="320040"/>
+            <a:ext cx="10652760" cy="5998464"/>
+          </a:xfrm>
+          <a:prstGeom prst="rect">
+            <a:avLst/>
+          </a:prstGeom>
+        </p:spPr>
+      </p:pic>
+      <p:sp>
+        <p:nvSpPr>
+          <p:cNvPr id="4" name="Text 0"/>
+          <p:cNvSpPr/>
+          <p:nvPr/>
+        </p:nvSpPr>
+        <p:spPr>
+          <a:xfrm>
+            <a:off x="457200" y="6473952"/>
+            <a:ext cx="7315200" cy="274320"/>
+          </a:xfrm>
+          <a:prstGeom prst="rect">
+            <a:avLst/>
+          </a:prstGeom>
+          <a:noFill/>
+          <a:ln/>
+        </p:spPr>
+        <p:txBody>
+          <a:bodyPr wrap="square" rtlCol="0" anchor="ctr"/>
+          <a:lstStyle/>
+          <a:p>
+            <a:pPr indent="0" marL="0">
+              <a:buNone/>
+            </a:pPr>
+            <a:r>
+              <a:rPr lang="en-US" sz="900" dirty="0">
+                <a:solidFill>
+                  <a:srgbClr val="5C6B8A"/>
+                </a:solidFill>
+                <a:latin typeface="Calibri" pitchFamily="34" charset="0"/>
+                <a:ea typeface="Calibri" pitchFamily="34" charset="-122"/>
+                <a:cs typeface="Calibri" pitchFamily="34" charset="-120"/>
+              </a:rPr>
+              <a:t>Secure Kubernetes on Azure — Portfolio Showcase</a:t>
+            </a:r>
+            <a:endParaRPr lang="en-US" sz="900" dirty="0"/>
+          </a:p>
+        </p:txBody>
+      </p:sp>
+      <p:sp>
+        <p:nvSpPr>
+          <p:cNvPr id="5" name="Text 1"/>
+          <p:cNvSpPr/>
+          <p:nvPr/>
+        </p:nvSpPr>
+        <p:spPr>
+          <a:xfrm>
+            <a:off x="11274552" y="6473952"/>
+            <a:ext cx="457200" cy="274320"/>
+          </a:xfrm>
+          <a:prstGeom prst="rect">
+            <a:avLst/>
+          </a:prstGeom>
+          <a:noFill/>
+          <a:ln/>
+        </p:spPr>
+        <p:txBody>
+          <a:bodyPr wrap="square" rtlCol="0" anchor="ctr"/>
+          <a:lstStyle/>
+          <a:p>
+            <a:pPr algn="r" indent="0" marL="0">
+              <a:buNone/>
+            </a:pPr>
+            <a:r>
+              <a:rPr lang="en-US" sz="900" dirty="0">
+                <a:solidFill>
+                  <a:srgbClr val="5C6B8A"/>
+                </a:solidFill>
+                <a:latin typeface="Calibri" pitchFamily="34" charset="0"/>
+                <a:ea typeface="Calibri" pitchFamily="34" charset="-122"/>
+                <a:cs typeface="Calibri" pitchFamily="34" charset="-120"/>
+              </a:rPr>
+              <a:t>3</a:t>
+            </a:r>
+            <a:endParaRPr lang="en-US" sz="900" dirty="0"/>
+          </a:p>
+        </p:txBody>
+      </p:sp>
+    </p:spTree>
+  </p:cSld>
+  <p:clrMapOvr>
+    <a:masterClrMapping/>
+  </p:clrMapOvr>
+</p:sld>
+</file>
+
+<file path=ppt/slides/slide4.xml><?xml version="1.0" encoding="utf-8"?>
+<p:sld xmlns:a="http://schemas.openxmlformats.org/drawingml/2006/main" xmlns:r="http://schemas.openxmlformats.org/officeDocument/2006/relationships" xmlns:p="http://schemas.openxmlformats.org/presentationml/2006/main">
+  <p:cSld name="Slide 4">
+    <p:bg>
+      <p:bgPr>
+        <a:solidFill>
           <a:srgbClr val="1E2761"/>
         </a:solidFill>
       </p:bgPr>
@@ -3308,7 +3531,7 @@
                 <a:ea typeface="Calibri" pitchFamily="34" charset="-122"/>
                 <a:cs typeface="Calibri" pitchFamily="34" charset="-120"/>
               </a:rPr>
-              <a:t>3</a:t>
+              <a:t>4</a:t>
             </a:r>
             <a:endParaRPr lang="en-US" sz="900" dirty="0"/>
           </a:p>
@@ -3322,9 +3545,9 @@
 </p:sld>
 </file>
 
-<file path=ppt/slides/slide4.xml><?xml version="1.0" encoding="utf-8"?>
+<file path=ppt/slides/slide5.xml><?xml version="1.0" encoding="utf-8"?>
 <p:sld xmlns:a="http://schemas.openxmlformats.org/drawingml/2006/main" xmlns:r="http://schemas.openxmlformats.org/officeDocument/2006/relationships" xmlns:p="http://schemas.openxmlformats.org/presentationml/2006/main">
-  <p:cSld name="Slide 4">
+  <p:cSld name="Slide 5">
     <p:bg>
       <p:bgPr>
         <a:solidFill>

</xml_diff>